<commit_message>
Add highlighted project repository link to slide 6
</commit_message>
<xml_diff>
--- a/1_Presentation/MilkShield_SIH2026_Idea_PPT_v2.pptx
+++ b/1_Presentation/MilkShield_SIH2026_Idea_PPT_v2.pptx
@@ -15883,6 +15883,41 @@
               <a:t>DST, Govt. of India: affordable milk chilling at point of harvest</a:t>
             </a:r>
           </a:p>
+          <a:p>
+            <a:pPr>
+              <a:spcAft>
+                <a:spcPts val="400"/>
+              </a:spcAft>
+            </a:pPr>
+            <a:r>
+              <a:rPr sz="1050" b="1">
+                <a:solidFill>
+                  <a:srgbClr val="14283A"/>
+                </a:solidFill>
+                <a:latin typeface="Arial"/>
+              </a:rPr>
+              <a:t>[10] </a:t>
+            </a:r>
+            <a:r>
+              <a:rPr sz="1050" b="1">
+                <a:solidFill>
+                  <a:srgbClr val="14283A"/>
+                </a:solidFill>
+                <a:latin typeface="Arial"/>
+              </a:rPr>
+              <a:t>Project repository: </a:t>
+            </a:r>
+            <a:r>
+              <a:rPr sz="1050" b="1">
+                <a:solidFill>
+                  <a:srgbClr val="1565A0"/>
+                </a:solidFill>
+                <a:latin typeface="Arial"/>
+                <a:hlinkClick r:id="rId9"/>
+              </a:rPr>
+              <a:t>github.com/Sanmugavel1/MilkShield-SIH2026</a:t>
+            </a:r>
+          </a:p>
         </p:txBody>
       </p:sp>
       <p:sp>
@@ -15893,8 +15928,8 @@
         </p:nvSpPr>
         <p:spPr>
           <a:xfrm>
-            <a:off x="329184" y="5779008"/>
-            <a:ext cx="11530584" cy="457200"/>
+            <a:off x="329184" y="5559552"/>
+            <a:ext cx="11530584" cy="731520"/>
           </a:xfrm>
           <a:prstGeom prst="roundRect">
             <a:avLst>
@@ -15951,6 +15986,32 @@
                 <a:latin typeface="Arial"/>
               </a:rPr>
               <a:t>thermal model · wall heat-flow model · 2D CFD (milk cools evenly, top to bottom within 2.5 °C). Next: prototype field trial.</a:t>
+            </a:r>
+          </a:p>
+          <a:p>
+            <a:pPr algn="ctr">
+              <a:spcAft>
+                <a:spcPts val="0"/>
+              </a:spcAft>
+            </a:pPr>
+            <a:r>
+              <a:rPr sz="1500" b="1">
+                <a:solidFill>
+                  <a:srgbClr val="0B3C5D"/>
+                </a:solidFill>
+                <a:latin typeface="Arial"/>
+              </a:rPr>
+              <a:t>Full simulation code, results &amp; videos:  </a:t>
+            </a:r>
+            <a:r>
+              <a:rPr sz="1500" b="1" u="sng">
+                <a:solidFill>
+                  <a:srgbClr val="1565A0"/>
+                </a:solidFill>
+                <a:latin typeface="Arial"/>
+                <a:hlinkClick r:id="rId9"/>
+              </a:rPr>
+              <a:t>github.com/Sanmugavel1/MilkShield-SIH2026</a:t>
             </a:r>
           </a:p>
         </p:txBody>

</xml_diff>